<commit_message>
Add the random panel to the panel-space figure and show it on slide 27
three_panel/plot_space_three.py extends two_panel/plot_space.py with the uniform-random
panel: A k-means, B taxonomy-stratified original, C random (all 10,000 picks on the
clusterable set), D share of each panel's on-frame picks per density decile. The
population share is now drawn per decile: the 21st-neighbour distance takes only 166
distinct values over 210,779 sequences, so the deciles hold 7.7-12.6% of sequences,
not the flat 10% the two-panel figure drew. The script asserts its shares reproduce
three_panel/space_deciles_three.json, which the deck already quotes.

Slide 27 uses the new figure; its caption names panel C and explains the ticks. The
manuscript's F16 is unchanged (still the two-panel version).

Co-Authored-By: Claude Opus 5.5 <noreply@anthropic.com>
</commit_message>
<xml_diff>
--- a/presentations/prFBA_updates_2026-10.pptx
+++ b/presentations/prFBA_updates_2026-10.pptx
@@ -4164,7 +4164,7 @@
           <a:lstStyle/>
           <a:p>
             <a:r>
-              <a:t>Density ranking is stable in k — Spearman 0.964 between the 21st and 50th nearest neighbour. The figure predates the random panel; its decile shares are in the caption.</a:t>
+              <a:t>Density ranking is stable in k — Spearman 0.964 between the 21st and 50th nearest neighbour. Panel C is the uniform-random panel; all 10,000 of its organisms sit on the clusterable set. The manuscript's figure (F16) is still the two-panel version.</a:t>
             </a:r>
           </a:p>
         </p:txBody>
@@ -18684,7 +18684,7 @@
       </p:sp>
       <p:pic>
         <p:nvPicPr>
-          <p:cNvPr id="3" name="Picture 2" descr="F_panel_space.png"/>
+          <p:cNvPr id="3" name="Picture 2" descr="F_panel_space_three.png"/>
           <p:cNvPicPr>
             <a:picLocks noChangeAspect="1"/>
           </p:cNvPicPr>
@@ -18698,8 +18698,8 @@
         </p:blipFill>
         <p:spPr>
           <a:xfrm>
-            <a:off x="795528" y="1298448"/>
-            <a:ext cx="10607040" cy="4277032"/>
+            <a:off x="548640" y="1325880"/>
+            <a:ext cx="11094415" cy="3315714"/>
           </a:xfrm>
           <a:prstGeom prst="rect">
             <a:avLst/>
@@ -18714,8 +18714,8 @@
         </p:nvSpPr>
         <p:spPr>
           <a:xfrm>
-            <a:off x="548640" y="5650992"/>
-            <a:ext cx="11094415" cy="640080"/>
+            <a:off x="548640" y="4864608"/>
+            <a:ext cx="11094415" cy="1097280"/>
           </a:xfrm>
           <a:prstGeom prst="rect">
             <a:avLst/>
@@ -18733,17 +18733,36 @@
                 <a:spcPct val="106000"/>
               </a:lnSpc>
               <a:spcAft>
+                <a:spcPts val="600"/>
+              </a:spcAft>
+            </a:pPr>
+            <a:r>
+              <a:rPr sz="1200" b="0" i="0">
+                <a:solidFill>
+                  <a:srgbClr val="5B7179"/>
+                </a:solidFill>
+                <a:latin typeface="Calibri"/>
+              </a:rPr>
+              <a:t>The stratified panel over-weights the sparse space hardest — 49.1% of its picks from the two sparsest deciles, against 36.6% for k-means — while the random panel (C) tracks the population: 23.8% against 19.2%, and 12.4% of picks in the densest decile against the population's 12.6% (stratified 0.8%, k-means 4.1%). The dense deciles are where self-exclusion empties a 20-hit record.</a:t>
+            </a:r>
+          </a:p>
+          <a:p>
+            <a:pPr algn="l">
+              <a:lnSpc>
+                <a:spcPct val="104000"/>
+              </a:lnSpc>
+              <a:spcAft>
                 <a:spcPts val="0"/>
               </a:spcAft>
             </a:pPr>
             <a:r>
-              <a:rPr sz="1200" b="0" i="0">
+              <a:rPr sz="1100" b="0" i="0">
                 <a:solidFill>
                   <a:srgbClr val="5B7179"/>
                 </a:solidFill>
                 <a:latin typeface="Calibri"/>
               </a:rPr>
-              <a:t>The stratified panel over-weights the sparse space hardest — 49.1% of its picks from the two sparsest deciles, against 36.6% for k-means — while the random panel (not drawn) tracks the population: 23.8% against 19.2%, and 12.4% of picks in the densest decile against the population's 12.6% (stratified 0.8%, k-means 4.1%). The dense deciles are where self-exclusion empties a 20-hit record.</a:t>
+              <a:t>Black ticks in D are each decile's share of all sequences: the density measure is heavily tied (166 distinct values), so the deciles hold 7.7–12.6% of sequences rather than 10% each.</a:t>
             </a:r>
           </a:p>
         </p:txBody>
@@ -18782,7 +18801,7 @@
                 </a:solidFill>
                 <a:latin typeface="Calibri"/>
               </a:rPr>
-              <a:t>9,097 of the original panel's 10,000 organisms have a position in this space (the rest have short or atypical 16S, or a sequence the index credits to no admissible taxon); shares are of each panel's on-frame picks</a:t>
+              <a:t>9,097 of the original panel's 10,000 organisms have a position in this space (the rest have short or atypical 16S, or a sequence the index credits to no admissible taxon); all 10,000 k-means and random picks do. Shares are of each panel's on-frame picks</a:t>
             </a:r>
           </a:p>
         </p:txBody>

</xml_diff>